<commit_message>
Ajusta entregables del Taller 7 y corrige inconsistencias del ejemplo
- En clase se trabaja sobre el cliente real; RedExpress queda como ejemplo guiado.
- Nuevos entregables: to-be-proceso.drawio, matriz-decision.md y el PDF obligatorio.
- Plantilla de matriz de brechas (brechas, capacidades y paquetes de trabajo).
- Peso, plazo y carpeta del repositorio del equipo en el README.
- Tiempo de la opcion A coherente con el Paso 2 (puntua solo la implementacion).
- El checklist del Taller 6 no tiene estado Brecha: se usa Parcial.
- Presentacion en version para estudiantes, sin notas del orador.
</commit_message>
<xml_diff>
--- a/7. Oportunidades_Soluciones.pptx
+++ b/7. Oportunidades_Soluciones.pptx
@@ -1396,2118 +1396,6 @@
     </a:lvl9pPr>
   </p:notesStyle>
 </p:notesMaster>
-</file>
-
-<file path=ppt/notesSlides/notesSlide1.xml><?xml version="1.0" encoding="utf-8"?>
-<p:notes xmlns:a="http://schemas.openxmlformats.org/drawingml/2006/main" xmlns:r="http://schemas.openxmlformats.org/officeDocument/2006/relationships" xmlns:p="http://schemas.openxmlformats.org/presentationml/2006/main">
-  <p:cSld>
-    <p:spTree>
-      <p:nvGrpSpPr>
-        <p:cNvPr id="1" name=""/>
-        <p:cNvGrpSpPr/>
-        <p:nvPr/>
-      </p:nvGrpSpPr>
-      <p:grpSpPr>
-        <a:xfrm>
-          <a:off x="0" y="0"/>
-          <a:ext cx="0" cy="0"/>
-          <a:chOff x="0" y="0"/>
-          <a:chExt cx="0" cy="0"/>
-        </a:xfrm>
-      </p:grpSpPr>
-      <p:sp>
-        <p:nvSpPr>
-          <p:cNvPr id="2" name="Slide Image Placeholder 1"/>
-          <p:cNvSpPr>
-            <a:spLocks noGrp="1" noRot="1" noChangeAspect="1"/>
-          </p:cNvSpPr>
-          <p:nvPr>
-            <p:ph type="sldImg"/>
-          </p:nvPr>
-        </p:nvSpPr>
-        <p:spPr/>
-      </p:sp>
-      <p:sp>
-        <p:nvSpPr>
-          <p:cNvPr id="3" name="Notes Placeholder 2"/>
-          <p:cNvSpPr>
-            <a:spLocks noGrp="1"/>
-          </p:cNvSpPr>
-          <p:nvPr>
-            <p:ph type="body" idx="1"/>
-          </p:nvPr>
-        </p:nvSpPr>
-        <p:spPr/>
-        <p:txBody>
-          <a:bodyPr/>
-          <a:lstStyle/>
-          <a:p>
-            <a:r>
-              <a:rPr lang="en-US" dirty="0"/>
-              <a:t>Hilo de la clase: primero entendemos el contexto (AS-IS y brechas), luego armamos posibles soluciones, y al final aprendemos a decidir entre ellas con un método defendible. Todo con un mismo ejemplo: RedExpress.</a:t>
-            </a:r>
-            <a:endParaRPr lang="en-US" dirty="0"/>
-          </a:p>
-        </p:txBody>
-      </p:sp>
-      <p:sp>
-        <p:nvSpPr>
-          <p:cNvPr id="4" name="Slide Number Placeholder 3"/>
-          <p:cNvSpPr>
-            <a:spLocks noGrp="1"/>
-          </p:cNvSpPr>
-          <p:nvPr>
-            <p:ph type="sldNum" sz="quarter" idx="10"/>
-          </p:nvPr>
-        </p:nvSpPr>
-        <p:spPr/>
-        <p:txBody>
-          <a:bodyPr/>
-          <a:lstStyle/>
-          <a:p>
-            <a:fld id="{F7021451-1387-4CA6-816F-3879F97B5CBC}" type="slidenum">
-              <a:rPr lang="en-US"/>
-              <a:t>1</a:t>
-            </a:fld>
-            <a:endParaRPr lang="en-US"/>
-          </a:p>
-        </p:txBody>
-      </p:sp>
-    </p:spTree>
-    <p:extLst>
-      <p:ext uri="{BB962C8B-B14F-4D97-AF65-F5344CB8AC3E}">
-        <p14:creationId xmlns:p14="http://schemas.microsoft.com/office/powerpoint/2010/main" val="1024086991"/>
-      </p:ext>
-    </p:extLst>
-  </p:cSld>
-  <p:clrMapOvr>
-    <a:masterClrMapping/>
-  </p:clrMapOvr>
-</p:notes>
-</file>
-
-<file path=ppt/notesSlides/notesSlide10.xml><?xml version="1.0" encoding="utf-8"?>
-<p:notes xmlns:a="http://schemas.openxmlformats.org/drawingml/2006/main" xmlns:r="http://schemas.openxmlformats.org/officeDocument/2006/relationships" xmlns:p="http://schemas.openxmlformats.org/presentationml/2006/main">
-  <p:cSld>
-    <p:spTree>
-      <p:nvGrpSpPr>
-        <p:cNvPr id="1" name=""/>
-        <p:cNvGrpSpPr/>
-        <p:nvPr/>
-      </p:nvGrpSpPr>
-      <p:grpSpPr>
-        <a:xfrm>
-          <a:off x="0" y="0"/>
-          <a:ext cx="0" cy="0"/>
-          <a:chOff x="0" y="0"/>
-          <a:chExt cx="0" cy="0"/>
-        </a:xfrm>
-      </p:grpSpPr>
-      <p:sp>
-        <p:nvSpPr>
-          <p:cNvPr id="2" name="Slide Image Placeholder 1"/>
-          <p:cNvSpPr>
-            <a:spLocks noGrp="1" noRot="1" noChangeAspect="1"/>
-          </p:cNvSpPr>
-          <p:nvPr>
-            <p:ph type="sldImg"/>
-          </p:nvPr>
-        </p:nvSpPr>
-        <p:spPr/>
-      </p:sp>
-      <p:sp>
-        <p:nvSpPr>
-          <p:cNvPr id="3" name="Notes Placeholder 2"/>
-          <p:cNvSpPr>
-            <a:spLocks noGrp="1"/>
-          </p:cNvSpPr>
-          <p:nvPr>
-            <p:ph type="body" idx="1"/>
-          </p:nvPr>
-        </p:nvSpPr>
-        <p:spPr/>
-        <p:txBody>
-          <a:bodyPr/>
-          <a:lstStyle/>
-          <a:p>
-            <a:r>
-              <a:rPr lang="en-US" dirty="0"/>
-              <a:t>Es el marco de decisión de ocho pasos del Módulo 8 (Gobierno de Arquitectura). Aquí se practica; en el Taller 9 se registra el resultado como ADR.</a:t>
-            </a:r>
-            <a:endParaRPr lang="en-US" dirty="0"/>
-          </a:p>
-        </p:txBody>
-      </p:sp>
-      <p:sp>
-        <p:nvSpPr>
-          <p:cNvPr id="4" name="Slide Number Placeholder 3"/>
-          <p:cNvSpPr>
-            <a:spLocks noGrp="1"/>
-          </p:cNvSpPr>
-          <p:nvPr>
-            <p:ph type="sldNum" sz="quarter" idx="10"/>
-          </p:nvPr>
-        </p:nvSpPr>
-        <p:spPr/>
-        <p:txBody>
-          <a:bodyPr/>
-          <a:lstStyle/>
-          <a:p>
-            <a:fld id="{F7021451-1387-4CA6-816F-3879F97B5CBC}" type="slidenum">
-              <a:rPr lang="en-US"/>
-              <a:t>10</a:t>
-            </a:fld>
-            <a:endParaRPr lang="en-US"/>
-          </a:p>
-        </p:txBody>
-      </p:sp>
-    </p:spTree>
-    <p:extLst>
-      <p:ext uri="{BB962C8B-B14F-4D97-AF65-F5344CB8AC3E}">
-        <p14:creationId xmlns:p14="http://schemas.microsoft.com/office/powerpoint/2010/main" val="1024086991"/>
-      </p:ext>
-    </p:extLst>
-  </p:cSld>
-  <p:clrMapOvr>
-    <a:masterClrMapping/>
-  </p:clrMapOvr>
-</p:notes>
-</file>
-
-<file path=ppt/notesSlides/notesSlide11.xml><?xml version="1.0" encoding="utf-8"?>
-<p:notes xmlns:a="http://schemas.openxmlformats.org/drawingml/2006/main" xmlns:r="http://schemas.openxmlformats.org/officeDocument/2006/relationships" xmlns:p="http://schemas.openxmlformats.org/presentationml/2006/main">
-  <p:cSld>
-    <p:spTree>
-      <p:nvGrpSpPr>
-        <p:cNvPr id="1" name=""/>
-        <p:cNvGrpSpPr/>
-        <p:nvPr/>
-      </p:nvGrpSpPr>
-      <p:grpSpPr>
-        <a:xfrm>
-          <a:off x="0" y="0"/>
-          <a:ext cx="0" cy="0"/>
-          <a:chOff x="0" y="0"/>
-          <a:chExt cx="0" cy="0"/>
-        </a:xfrm>
-      </p:grpSpPr>
-      <p:sp>
-        <p:nvSpPr>
-          <p:cNvPr id="2" name="Slide Image Placeholder 1"/>
-          <p:cNvSpPr>
-            <a:spLocks noGrp="1" noRot="1" noChangeAspect="1"/>
-          </p:cNvSpPr>
-          <p:nvPr>
-            <p:ph type="sldImg"/>
-          </p:nvPr>
-        </p:nvSpPr>
-        <p:spPr/>
-      </p:sp>
-      <p:sp>
-        <p:nvSpPr>
-          <p:cNvPr id="3" name="Notes Placeholder 2"/>
-          <p:cNvSpPr>
-            <a:spLocks noGrp="1"/>
-          </p:cNvSpPr>
-          <p:nvPr>
-            <p:ph type="body" idx="1"/>
-          </p:nvPr>
-        </p:nvSpPr>
-        <p:spPr/>
-        <p:txBody>
-          <a:bodyPr/>
-          <a:lstStyle/>
-          <a:p>
-            <a:r>
-              <a:rPr lang="en-US" dirty="0"/>
-              <a:t>Regla práctica: si su enunciado contiene el nombre de una tecnología o la palabra 'necesitamos', reescríbalo. Fechas, dólares y volúmenes son supuestos del ejemplo.</a:t>
-            </a:r>
-            <a:endParaRPr lang="en-US" dirty="0"/>
-          </a:p>
-        </p:txBody>
-      </p:sp>
-      <p:sp>
-        <p:nvSpPr>
-          <p:cNvPr id="4" name="Slide Number Placeholder 3"/>
-          <p:cNvSpPr>
-            <a:spLocks noGrp="1"/>
-          </p:cNvSpPr>
-          <p:nvPr>
-            <p:ph type="sldNum" sz="quarter" idx="10"/>
-          </p:nvPr>
-        </p:nvSpPr>
-        <p:spPr/>
-        <p:txBody>
-          <a:bodyPr/>
-          <a:lstStyle/>
-          <a:p>
-            <a:fld id="{F7021451-1387-4CA6-816F-3879F97B5CBC}" type="slidenum">
-              <a:rPr lang="en-US"/>
-              <a:t>11</a:t>
-            </a:fld>
-            <a:endParaRPr lang="en-US"/>
-          </a:p>
-        </p:txBody>
-      </p:sp>
-    </p:spTree>
-    <p:extLst>
-      <p:ext uri="{BB962C8B-B14F-4D97-AF65-F5344CB8AC3E}">
-        <p14:creationId xmlns:p14="http://schemas.microsoft.com/office/powerpoint/2010/main" val="1024086991"/>
-      </p:ext>
-    </p:extLst>
-  </p:cSld>
-  <p:clrMapOvr>
-    <a:masterClrMapping/>
-  </p:clrMapOvr>
-</p:notes>
-</file>
-
-<file path=ppt/notesSlides/notesSlide12.xml><?xml version="1.0" encoding="utf-8"?>
-<p:notes xmlns:a="http://schemas.openxmlformats.org/drawingml/2006/main" xmlns:r="http://schemas.openxmlformats.org/officeDocument/2006/relationships" xmlns:p="http://schemas.openxmlformats.org/presentationml/2006/main">
-  <p:cSld>
-    <p:spTree>
-      <p:nvGrpSpPr>
-        <p:cNvPr id="1" name=""/>
-        <p:cNvGrpSpPr/>
-        <p:nvPr/>
-      </p:nvGrpSpPr>
-      <p:grpSpPr>
-        <a:xfrm>
-          <a:off x="0" y="0"/>
-          <a:ext cx="0" cy="0"/>
-          <a:chOff x="0" y="0"/>
-          <a:chExt cx="0" cy="0"/>
-        </a:xfrm>
-      </p:grpSpPr>
-      <p:sp>
-        <p:nvSpPr>
-          <p:cNvPr id="2" name="Slide Image Placeholder 1"/>
-          <p:cNvSpPr>
-            <a:spLocks noGrp="1" noRot="1" noChangeAspect="1"/>
-          </p:cNvSpPr>
-          <p:nvPr>
-            <p:ph type="sldImg"/>
-          </p:nvPr>
-        </p:nvSpPr>
-        <p:spPr/>
-      </p:sp>
-      <p:sp>
-        <p:nvSpPr>
-          <p:cNvPr id="3" name="Notes Placeholder 2"/>
-          <p:cNvSpPr>
-            <a:spLocks noGrp="1"/>
-          </p:cNvSpPr>
-          <p:nvPr>
-            <p:ph type="body" idx="1"/>
-          </p:nvPr>
-        </p:nvSpPr>
-        <p:spPr/>
-        <p:txBody>
-          <a:bodyPr/>
-          <a:lstStyle/>
-          <a:p>
-            <a:r>
-              <a:rPr lang="en-US" dirty="0"/>
-              <a:t>Cada criterio lleva una escala explícita para que dos personas puntúen igual. 5 siempre es lo más favorable (más barato, más simple, más rápido). Rangos intermedios de costo: 4 = 100-500, 3 = 500-800, 2 = 800-1.200. Tiempo: 4 = 2-3 sem., 3 = 4-6, 2 = 7-10.</a:t>
-            </a:r>
-            <a:endParaRPr lang="en-US" dirty="0"/>
-          </a:p>
-        </p:txBody>
-      </p:sp>
-      <p:sp>
-        <p:nvSpPr>
-          <p:cNvPr id="4" name="Slide Number Placeholder 3"/>
-          <p:cNvSpPr>
-            <a:spLocks noGrp="1"/>
-          </p:cNvSpPr>
-          <p:nvPr>
-            <p:ph type="sldNum" sz="quarter" idx="10"/>
-          </p:nvPr>
-        </p:nvSpPr>
-        <p:spPr/>
-        <p:txBody>
-          <a:bodyPr/>
-          <a:lstStyle/>
-          <a:p>
-            <a:fld id="{F7021451-1387-4CA6-816F-3879F97B5CBC}" type="slidenum">
-              <a:rPr lang="en-US"/>
-              <a:t>12</a:t>
-            </a:fld>
-            <a:endParaRPr lang="en-US"/>
-          </a:p>
-        </p:txBody>
-      </p:sp>
-    </p:spTree>
-    <p:extLst>
-      <p:ext uri="{BB962C8B-B14F-4D97-AF65-F5344CB8AC3E}">
-        <p14:creationId xmlns:p14="http://schemas.microsoft.com/office/powerpoint/2010/main" val="1024086991"/>
-      </p:ext>
-    </p:extLst>
-  </p:cSld>
-  <p:clrMapOvr>
-    <a:masterClrMapping/>
-  </p:clrMapOvr>
-</p:notes>
-</file>
-
-<file path=ppt/notesSlides/notesSlide13.xml><?xml version="1.0" encoding="utf-8"?>
-<p:notes xmlns:a="http://schemas.openxmlformats.org/drawingml/2006/main" xmlns:r="http://schemas.openxmlformats.org/officeDocument/2006/relationships" xmlns:p="http://schemas.openxmlformats.org/presentationml/2006/main">
-  <p:cSld>
-    <p:spTree>
-      <p:nvGrpSpPr>
-        <p:cNvPr id="1" name=""/>
-        <p:cNvGrpSpPr/>
-        <p:nvPr/>
-      </p:nvGrpSpPr>
-      <p:grpSpPr>
-        <a:xfrm>
-          <a:off x="0" y="0"/>
-          <a:ext cx="0" cy="0"/>
-          <a:chOff x="0" y="0"/>
-          <a:chExt cx="0" cy="0"/>
-        </a:xfrm>
-      </p:grpSpPr>
-      <p:sp>
-        <p:nvSpPr>
-          <p:cNvPr id="2" name="Slide Image Placeholder 1"/>
-          <p:cNvSpPr>
-            <a:spLocks noGrp="1" noRot="1" noChangeAspect="1"/>
-          </p:cNvSpPr>
-          <p:nvPr>
-            <p:ph type="sldImg"/>
-          </p:nvPr>
-        </p:nvSpPr>
-        <p:spPr/>
-      </p:sp>
-      <p:sp>
-        <p:nvSpPr>
-          <p:cNvPr id="3" name="Notes Placeholder 2"/>
-          <p:cNvSpPr>
-            <a:spLocks noGrp="1"/>
-          </p:cNvSpPr>
-          <p:nvPr>
-            <p:ph type="body" idx="1"/>
-          </p:nvPr>
-        </p:nvSpPr>
-        <p:spPr/>
-        <p:txBody>
-          <a:bodyPr/>
-          <a:lstStyle/>
-          <a:p>
-            <a:r>
-              <a:rPr lang="en-US" dirty="0"/>
-              <a:t>Se consulta a quien sabe (aporta datos) y a quien le afecta (aporta el umbral de lo tolerable). Anotar quién dijo qué permite defender cada puntaje.</a:t>
-            </a:r>
-            <a:endParaRPr lang="en-US" dirty="0"/>
-          </a:p>
-        </p:txBody>
-      </p:sp>
-      <p:sp>
-        <p:nvSpPr>
-          <p:cNvPr id="4" name="Slide Number Placeholder 3"/>
-          <p:cNvSpPr>
-            <a:spLocks noGrp="1"/>
-          </p:cNvSpPr>
-          <p:nvPr>
-            <p:ph type="sldNum" sz="quarter" idx="10"/>
-          </p:nvPr>
-        </p:nvSpPr>
-        <p:spPr/>
-        <p:txBody>
-          <a:bodyPr/>
-          <a:lstStyle/>
-          <a:p>
-            <a:fld id="{F7021451-1387-4CA6-816F-3879F97B5CBC}" type="slidenum">
-              <a:rPr lang="en-US"/>
-              <a:t>13</a:t>
-            </a:fld>
-            <a:endParaRPr lang="en-US"/>
-          </a:p>
-        </p:txBody>
-      </p:sp>
-    </p:spTree>
-    <p:extLst>
-      <p:ext uri="{BB962C8B-B14F-4D97-AF65-F5344CB8AC3E}">
-        <p14:creationId xmlns:p14="http://schemas.microsoft.com/office/powerpoint/2010/main" val="1024086991"/>
-      </p:ext>
-    </p:extLst>
-  </p:cSld>
-  <p:clrMapOvr>
-    <a:masterClrMapping/>
-  </p:clrMapOvr>
-</p:notes>
-</file>
-
-<file path=ppt/notesSlides/notesSlide14.xml><?xml version="1.0" encoding="utf-8"?>
-<p:notes xmlns:a="http://schemas.openxmlformats.org/drawingml/2006/main" xmlns:r="http://schemas.openxmlformats.org/officeDocument/2006/relationships" xmlns:p="http://schemas.openxmlformats.org/presentationml/2006/main">
-  <p:cSld>
-    <p:spTree>
-      <p:nvGrpSpPr>
-        <p:cNvPr id="1" name=""/>
-        <p:cNvGrpSpPr/>
-        <p:nvPr/>
-      </p:nvGrpSpPr>
-      <p:grpSpPr>
-        <a:xfrm>
-          <a:off x="0" y="0"/>
-          <a:ext cx="0" cy="0"/>
-          <a:chOff x="0" y="0"/>
-          <a:chExt cx="0" cy="0"/>
-        </a:xfrm>
-      </p:grpSpPr>
-      <p:sp>
-        <p:nvSpPr>
-          <p:cNvPr id="2" name="Slide Image Placeholder 1"/>
-          <p:cNvSpPr>
-            <a:spLocks noGrp="1" noRot="1" noChangeAspect="1"/>
-          </p:cNvSpPr>
-          <p:nvPr>
-            <p:ph type="sldImg"/>
-          </p:nvPr>
-        </p:nvSpPr>
-        <p:spPr/>
-      </p:sp>
-      <p:sp>
-        <p:nvSpPr>
-          <p:cNvPr id="3" name="Notes Placeholder 2"/>
-          <p:cNvSpPr>
-            <a:spLocks noGrp="1"/>
-          </p:cNvSpPr>
-          <p:nvPr>
-            <p:ph type="body" idx="1"/>
-          </p:nvPr>
-        </p:nvSpPr>
-        <p:spPr/>
-        <p:txBody>
-          <a:bodyPr/>
-          <a:lstStyle/>
-          <a:p>
-            <a:r>
-              <a:rPr lang="en-US" dirty="0"/>
-              <a:t>Escala 1-5, donde 5 siempre es lo más favorable. Fíjese en C: saca 5 en costo, complejidad y tiempo, pero 1 en disponibilidad, que es justo lo que el problema exige.</a:t>
-            </a:r>
-            <a:endParaRPr lang="en-US" dirty="0"/>
-          </a:p>
-        </p:txBody>
-      </p:sp>
-      <p:sp>
-        <p:nvSpPr>
-          <p:cNvPr id="4" name="Slide Number Placeholder 3"/>
-          <p:cNvSpPr>
-            <a:spLocks noGrp="1"/>
-          </p:cNvSpPr>
-          <p:nvPr>
-            <p:ph type="sldNum" sz="quarter" idx="10"/>
-          </p:nvPr>
-        </p:nvSpPr>
-        <p:spPr/>
-        <p:txBody>
-          <a:bodyPr/>
-          <a:lstStyle/>
-          <a:p>
-            <a:fld id="{F7021451-1387-4CA6-816F-3879F97B5CBC}" type="slidenum">
-              <a:rPr lang="en-US"/>
-              <a:t>14</a:t>
-            </a:fld>
-            <a:endParaRPr lang="en-US"/>
-          </a:p>
-        </p:txBody>
-      </p:sp>
-    </p:spTree>
-    <p:extLst>
-      <p:ext uri="{BB962C8B-B14F-4D97-AF65-F5344CB8AC3E}">
-        <p14:creationId xmlns:p14="http://schemas.microsoft.com/office/powerpoint/2010/main" val="1024086991"/>
-      </p:ext>
-    </p:extLst>
-  </p:cSld>
-  <p:clrMapOvr>
-    <a:masterClrMapping/>
-  </p:clrMapOvr>
-</p:notes>
-</file>
-
-<file path=ppt/notesSlides/notesSlide15.xml><?xml version="1.0" encoding="utf-8"?>
-<p:notes xmlns:a="http://schemas.openxmlformats.org/drawingml/2006/main" xmlns:r="http://schemas.openxmlformats.org/officeDocument/2006/relationships" xmlns:p="http://schemas.openxmlformats.org/presentationml/2006/main">
-  <p:cSld>
-    <p:spTree>
-      <p:nvGrpSpPr>
-        <p:cNvPr id="1" name=""/>
-        <p:cNvGrpSpPr/>
-        <p:nvPr/>
-      </p:nvGrpSpPr>
-      <p:grpSpPr>
-        <a:xfrm>
-          <a:off x="0" y="0"/>
-          <a:ext cx="0" cy="0"/>
-          <a:chOff x="0" y="0"/>
-          <a:chExt cx="0" cy="0"/>
-        </a:xfrm>
-      </p:grpSpPr>
-      <p:sp>
-        <p:nvSpPr>
-          <p:cNvPr id="2" name="Slide Image Placeholder 1"/>
-          <p:cNvSpPr>
-            <a:spLocks noGrp="1" noRot="1" noChangeAspect="1"/>
-          </p:cNvSpPr>
-          <p:nvPr>
-            <p:ph type="sldImg"/>
-          </p:nvPr>
-        </p:nvSpPr>
-        <p:spPr/>
-      </p:sp>
-      <p:sp>
-        <p:nvSpPr>
-          <p:cNvPr id="3" name="Notes Placeholder 2"/>
-          <p:cNvSpPr>
-            <a:spLocks noGrp="1"/>
-          </p:cNvSpPr>
-          <p:nvPr>
-            <p:ph type="body" idx="1"/>
-          </p:nvPr>
-        </p:nvSpPr>
-        <p:spPr/>
-        <p:txBody>
-          <a:bodyPr/>
-          <a:lstStyle/>
-          <a:p>
-            <a:r>
-              <a:rPr lang="en-US" dirty="0"/>
-              <a:t>Cálculo: puntaje × peso de cada criterio, sumado. Los pesos suman 100 % (0,35 + 0,25 + 0,20 + 0,20).</a:t>
-            </a:r>
-            <a:endParaRPr lang="en-US" dirty="0"/>
-          </a:p>
-        </p:txBody>
-      </p:sp>
-      <p:sp>
-        <p:nvSpPr>
-          <p:cNvPr id="4" name="Slide Number Placeholder 3"/>
-          <p:cNvSpPr>
-            <a:spLocks noGrp="1"/>
-          </p:cNvSpPr>
-          <p:nvPr>
-            <p:ph type="sldNum" sz="quarter" idx="10"/>
-          </p:nvPr>
-        </p:nvSpPr>
-        <p:spPr/>
-        <p:txBody>
-          <a:bodyPr/>
-          <a:lstStyle/>
-          <a:p>
-            <a:fld id="{F7021451-1387-4CA6-816F-3879F97B5CBC}" type="slidenum">
-              <a:rPr lang="en-US"/>
-              <a:t>15</a:t>
-            </a:fld>
-            <a:endParaRPr lang="en-US"/>
-          </a:p>
-        </p:txBody>
-      </p:sp>
-    </p:spTree>
-    <p:extLst>
-      <p:ext uri="{BB962C8B-B14F-4D97-AF65-F5344CB8AC3E}">
-        <p14:creationId xmlns:p14="http://schemas.microsoft.com/office/powerpoint/2010/main" val="1024086991"/>
-      </p:ext>
-    </p:extLst>
-  </p:cSld>
-  <p:clrMapOvr>
-    <a:masterClrMapping/>
-  </p:clrMapOvr>
-</p:notes>
-</file>
-
-<file path=ppt/notesSlides/notesSlide16.xml><?xml version="1.0" encoding="utf-8"?>
-<p:notes xmlns:a="http://schemas.openxmlformats.org/drawingml/2006/main" xmlns:r="http://schemas.openxmlformats.org/officeDocument/2006/relationships" xmlns:p="http://schemas.openxmlformats.org/presentationml/2006/main">
-  <p:cSld>
-    <p:spTree>
-      <p:nvGrpSpPr>
-        <p:cNvPr id="1" name=""/>
-        <p:cNvGrpSpPr/>
-        <p:nvPr/>
-      </p:nvGrpSpPr>
-      <p:grpSpPr>
-        <a:xfrm>
-          <a:off x="0" y="0"/>
-          <a:ext cx="0" cy="0"/>
-          <a:chOff x="0" y="0"/>
-          <a:chExt cx="0" cy="0"/>
-        </a:xfrm>
-      </p:grpSpPr>
-      <p:sp>
-        <p:nvSpPr>
-          <p:cNvPr id="2" name="Slide Image Placeholder 1"/>
-          <p:cNvSpPr>
-            <a:spLocks noGrp="1" noRot="1" noChangeAspect="1"/>
-          </p:cNvSpPr>
-          <p:nvPr>
-            <p:ph type="sldImg"/>
-          </p:nvPr>
-        </p:nvSpPr>
-        <p:spPr/>
-      </p:sp>
-      <p:sp>
-        <p:nvSpPr>
-          <p:cNvPr id="3" name="Notes Placeholder 2"/>
-          <p:cNvSpPr>
-            <a:spLocks noGrp="1"/>
-          </p:cNvSpPr>
-          <p:nvPr>
-            <p:ph type="body" idx="1"/>
-          </p:nvPr>
-        </p:nvSpPr>
-        <p:spPr/>
-        <p:txBody>
-          <a:bodyPr/>
-          <a:lstStyle/>
-          <a:p>
-            <a:r>
-              <a:rPr lang="en-US" dirty="0"/>
-              <a:t>Esta es la lámina que más se olvida. La matriz no decide por usted: le muestra qué pasa con distintos supuestos. Demostrar en vivo con la página visualizacion-opportunities-solutions.html del repo.</a:t>
-            </a:r>
-            <a:endParaRPr lang="en-US" dirty="0"/>
-          </a:p>
-        </p:txBody>
-      </p:sp>
-      <p:sp>
-        <p:nvSpPr>
-          <p:cNvPr id="4" name="Slide Number Placeholder 3"/>
-          <p:cNvSpPr>
-            <a:spLocks noGrp="1"/>
-          </p:cNvSpPr>
-          <p:nvPr>
-            <p:ph type="sldNum" sz="quarter" idx="10"/>
-          </p:nvPr>
-        </p:nvSpPr>
-        <p:spPr/>
-        <p:txBody>
-          <a:bodyPr/>
-          <a:lstStyle/>
-          <a:p>
-            <a:fld id="{F7021451-1387-4CA6-816F-3879F97B5CBC}" type="slidenum">
-              <a:rPr lang="en-US"/>
-              <a:t>16</a:t>
-            </a:fld>
-            <a:endParaRPr lang="en-US"/>
-          </a:p>
-        </p:txBody>
-      </p:sp>
-    </p:spTree>
-    <p:extLst>
-      <p:ext uri="{BB962C8B-B14F-4D97-AF65-F5344CB8AC3E}">
-        <p14:creationId xmlns:p14="http://schemas.microsoft.com/office/powerpoint/2010/main" val="1024086991"/>
-      </p:ext>
-    </p:extLst>
-  </p:cSld>
-  <p:clrMapOvr>
-    <a:masterClrMapping/>
-  </p:clrMapOvr>
-</p:notes>
-</file>
-
-<file path=ppt/notesSlides/notesSlide17.xml><?xml version="1.0" encoding="utf-8"?>
-<p:notes xmlns:a="http://schemas.openxmlformats.org/drawingml/2006/main" xmlns:r="http://schemas.openxmlformats.org/officeDocument/2006/relationships" xmlns:p="http://schemas.openxmlformats.org/presentationml/2006/main">
-  <p:cSld>
-    <p:spTree>
-      <p:nvGrpSpPr>
-        <p:cNvPr id="1" name=""/>
-        <p:cNvGrpSpPr/>
-        <p:nvPr/>
-      </p:nvGrpSpPr>
-      <p:grpSpPr>
-        <a:xfrm>
-          <a:off x="0" y="0"/>
-          <a:ext cx="0" cy="0"/>
-          <a:chOff x="0" y="0"/>
-          <a:chExt cx="0" cy="0"/>
-        </a:xfrm>
-      </p:grpSpPr>
-      <p:sp>
-        <p:nvSpPr>
-          <p:cNvPr id="2" name="Slide Image Placeholder 1"/>
-          <p:cNvSpPr>
-            <a:spLocks noGrp="1" noRot="1" noChangeAspect="1"/>
-          </p:cNvSpPr>
-          <p:nvPr>
-            <p:ph type="sldImg"/>
-          </p:nvPr>
-        </p:nvSpPr>
-        <p:spPr/>
-      </p:sp>
-      <p:sp>
-        <p:nvSpPr>
-          <p:cNvPr id="3" name="Notes Placeholder 2"/>
-          <p:cNvSpPr>
-            <a:spLocks noGrp="1"/>
-          </p:cNvSpPr>
-          <p:nvPr>
-            <p:ph type="body" idx="1"/>
-          </p:nvPr>
-        </p:nvSpPr>
-        <p:spPr/>
-        <p:txBody>
-          <a:bodyPr/>
-          <a:lstStyle/>
-          <a:p>
-            <a:r>
-              <a:rPr lang="en-US" dirty="0"/>
-              <a:t>La IA es muy buena ampliando opciones y generando la pregunta incómoda; es poco confiable dando cifras. Por eso cada afirmación suya se verifica o se recalcula.</a:t>
-            </a:r>
-            <a:endParaRPr lang="en-US" dirty="0"/>
-          </a:p>
-        </p:txBody>
-      </p:sp>
-      <p:sp>
-        <p:nvSpPr>
-          <p:cNvPr id="4" name="Slide Number Placeholder 3"/>
-          <p:cNvSpPr>
-            <a:spLocks noGrp="1"/>
-          </p:cNvSpPr>
-          <p:nvPr>
-            <p:ph type="sldNum" sz="quarter" idx="10"/>
-          </p:nvPr>
-        </p:nvSpPr>
-        <p:spPr/>
-        <p:txBody>
-          <a:bodyPr/>
-          <a:lstStyle/>
-          <a:p>
-            <a:fld id="{F7021451-1387-4CA6-816F-3879F97B5CBC}" type="slidenum">
-              <a:rPr lang="en-US"/>
-              <a:t>17</a:t>
-            </a:fld>
-            <a:endParaRPr lang="en-US"/>
-          </a:p>
-        </p:txBody>
-      </p:sp>
-    </p:spTree>
-    <p:extLst>
-      <p:ext uri="{BB962C8B-B14F-4D97-AF65-F5344CB8AC3E}">
-        <p14:creationId xmlns:p14="http://schemas.microsoft.com/office/powerpoint/2010/main" val="1024086991"/>
-      </p:ext>
-    </p:extLst>
-  </p:cSld>
-  <p:clrMapOvr>
-    <a:masterClrMapping/>
-  </p:clrMapOvr>
-</p:notes>
-</file>
-
-<file path=ppt/notesSlides/notesSlide18.xml><?xml version="1.0" encoding="utf-8"?>
-<p:notes xmlns:a="http://schemas.openxmlformats.org/drawingml/2006/main" xmlns:r="http://schemas.openxmlformats.org/officeDocument/2006/relationships" xmlns:p="http://schemas.openxmlformats.org/presentationml/2006/main">
-  <p:cSld>
-    <p:spTree>
-      <p:nvGrpSpPr>
-        <p:cNvPr id="1" name=""/>
-        <p:cNvGrpSpPr/>
-        <p:nvPr/>
-      </p:nvGrpSpPr>
-      <p:grpSpPr>
-        <a:xfrm>
-          <a:off x="0" y="0"/>
-          <a:ext cx="0" cy="0"/>
-          <a:chOff x="0" y="0"/>
-          <a:chExt cx="0" cy="0"/>
-        </a:xfrm>
-      </p:grpSpPr>
-      <p:sp>
-        <p:nvSpPr>
-          <p:cNvPr id="2" name="Slide Image Placeholder 1"/>
-          <p:cNvSpPr>
-            <a:spLocks noGrp="1" noRot="1" noChangeAspect="1"/>
-          </p:cNvSpPr>
-          <p:nvPr>
-            <p:ph type="sldImg"/>
-          </p:nvPr>
-        </p:nvSpPr>
-        <p:spPr/>
-      </p:sp>
-      <p:sp>
-        <p:nvSpPr>
-          <p:cNvPr id="3" name="Notes Placeholder 2"/>
-          <p:cNvSpPr>
-            <a:spLocks noGrp="1"/>
-          </p:cNvSpPr>
-          <p:nvPr>
-            <p:ph type="body" idx="1"/>
-          </p:nvPr>
-        </p:nvSpPr>
-        <p:spPr/>
-        <p:txBody>
-          <a:bodyPr/>
-          <a:lstStyle/>
-          <a:p>
-            <a:r>
-              <a:rPr lang="en-US" dirty="0"/>
-              <a:t>Resto del peso repartido en partes iguales entre los otros tres criterios. Comprobación: con 62,5 % ambos suman 3,875.</a:t>
-            </a:r>
-            <a:endParaRPr lang="en-US" dirty="0"/>
-          </a:p>
-        </p:txBody>
-      </p:sp>
-      <p:sp>
-        <p:nvSpPr>
-          <p:cNvPr id="4" name="Slide Number Placeholder 3"/>
-          <p:cNvSpPr>
-            <a:spLocks noGrp="1"/>
-          </p:cNvSpPr>
-          <p:nvPr>
-            <p:ph type="sldNum" sz="quarter" idx="10"/>
-          </p:nvPr>
-        </p:nvSpPr>
-        <p:spPr/>
-        <p:txBody>
-          <a:bodyPr/>
-          <a:lstStyle/>
-          <a:p>
-            <a:fld id="{F7021451-1387-4CA6-816F-3879F97B5CBC}" type="slidenum">
-              <a:rPr lang="en-US"/>
-              <a:t>18</a:t>
-            </a:fld>
-            <a:endParaRPr lang="en-US"/>
-          </a:p>
-        </p:txBody>
-      </p:sp>
-    </p:spTree>
-    <p:extLst>
-      <p:ext uri="{BB962C8B-B14F-4D97-AF65-F5344CB8AC3E}">
-        <p14:creationId xmlns:p14="http://schemas.microsoft.com/office/powerpoint/2010/main" val="1024086991"/>
-      </p:ext>
-    </p:extLst>
-  </p:cSld>
-  <p:clrMapOvr>
-    <a:masterClrMapping/>
-  </p:clrMapOvr>
-</p:notes>
-</file>
-
-<file path=ppt/notesSlides/notesSlide19.xml><?xml version="1.0" encoding="utf-8"?>
-<p:notes xmlns:a="http://schemas.openxmlformats.org/drawingml/2006/main" xmlns:r="http://schemas.openxmlformats.org/officeDocument/2006/relationships" xmlns:p="http://schemas.openxmlformats.org/presentationml/2006/main">
-  <p:cSld>
-    <p:spTree>
-      <p:nvGrpSpPr>
-        <p:cNvPr id="1" name=""/>
-        <p:cNvGrpSpPr/>
-        <p:nvPr/>
-      </p:nvGrpSpPr>
-      <p:grpSpPr>
-        <a:xfrm>
-          <a:off x="0" y="0"/>
-          <a:ext cx="0" cy="0"/>
-          <a:chOff x="0" y="0"/>
-          <a:chExt cx="0" cy="0"/>
-        </a:xfrm>
-      </p:grpSpPr>
-      <p:sp>
-        <p:nvSpPr>
-          <p:cNvPr id="2" name="Slide Image Placeholder 1"/>
-          <p:cNvSpPr>
-            <a:spLocks noGrp="1" noRot="1" noChangeAspect="1"/>
-          </p:cNvSpPr>
-          <p:nvPr>
-            <p:ph type="sldImg"/>
-          </p:nvPr>
-        </p:nvSpPr>
-        <p:spPr/>
-      </p:sp>
-      <p:sp>
-        <p:nvSpPr>
-          <p:cNvPr id="3" name="Notes Placeholder 2"/>
-          <p:cNvSpPr>
-            <a:spLocks noGrp="1"/>
-          </p:cNvSpPr>
-          <p:nvPr>
-            <p:ph type="body" idx="1"/>
-          </p:nvPr>
-        </p:nvSpPr>
-        <p:spPr/>
-        <p:txBody>
-          <a:bodyPr/>
-          <a:lstStyle/>
-          <a:p>
-            <a:r>
-              <a:rPr lang="en-US" dirty="0"/>
-              <a:t>Las reglas 3 y 4 son las que más se incumplen. La tríada letal y el patrón agéntico ya se vieron en el Taller 5 y en la guía de ArchiMate.</a:t>
-            </a:r>
-            <a:endParaRPr lang="en-US" dirty="0"/>
-          </a:p>
-        </p:txBody>
-      </p:sp>
-      <p:sp>
-        <p:nvSpPr>
-          <p:cNvPr id="4" name="Slide Number Placeholder 3"/>
-          <p:cNvSpPr>
-            <a:spLocks noGrp="1"/>
-          </p:cNvSpPr>
-          <p:nvPr>
-            <p:ph type="sldNum" sz="quarter" idx="10"/>
-          </p:nvPr>
-        </p:nvSpPr>
-        <p:spPr/>
-        <p:txBody>
-          <a:bodyPr/>
-          <a:lstStyle/>
-          <a:p>
-            <a:fld id="{F7021451-1387-4CA6-816F-3879F97B5CBC}" type="slidenum">
-              <a:rPr lang="en-US"/>
-              <a:t>19</a:t>
-            </a:fld>
-            <a:endParaRPr lang="en-US"/>
-          </a:p>
-        </p:txBody>
-      </p:sp>
-    </p:spTree>
-    <p:extLst>
-      <p:ext uri="{BB962C8B-B14F-4D97-AF65-F5344CB8AC3E}">
-        <p14:creationId xmlns:p14="http://schemas.microsoft.com/office/powerpoint/2010/main" val="1024086991"/>
-      </p:ext>
-    </p:extLst>
-  </p:cSld>
-  <p:clrMapOvr>
-    <a:masterClrMapping/>
-  </p:clrMapOvr>
-</p:notes>
-</file>
-
-<file path=ppt/notesSlides/notesSlide2.xml><?xml version="1.0" encoding="utf-8"?>
-<p:notes xmlns:a="http://schemas.openxmlformats.org/drawingml/2006/main" xmlns:r="http://schemas.openxmlformats.org/officeDocument/2006/relationships" xmlns:p="http://schemas.openxmlformats.org/presentationml/2006/main">
-  <p:cSld>
-    <p:spTree>
-      <p:nvGrpSpPr>
-        <p:cNvPr id="1" name=""/>
-        <p:cNvGrpSpPr/>
-        <p:nvPr/>
-      </p:nvGrpSpPr>
-      <p:grpSpPr>
-        <a:xfrm>
-          <a:off x="0" y="0"/>
-          <a:ext cx="0" cy="0"/>
-          <a:chOff x="0" y="0"/>
-          <a:chExt cx="0" cy="0"/>
-        </a:xfrm>
-      </p:grpSpPr>
-      <p:sp>
-        <p:nvSpPr>
-          <p:cNvPr id="2" name="Slide Image Placeholder 1"/>
-          <p:cNvSpPr>
-            <a:spLocks noGrp="1" noRot="1" noChangeAspect="1"/>
-          </p:cNvSpPr>
-          <p:nvPr>
-            <p:ph type="sldImg"/>
-          </p:nvPr>
-        </p:nvSpPr>
-        <p:spPr/>
-      </p:sp>
-      <p:sp>
-        <p:nvSpPr>
-          <p:cNvPr id="3" name="Notes Placeholder 2"/>
-          <p:cNvSpPr>
-            <a:spLocks noGrp="1"/>
-          </p:cNvSpPr>
-          <p:nvPr>
-            <p:ph type="body" idx="1"/>
-          </p:nvPr>
-        </p:nvSpPr>
-        <p:spPr/>
-        <p:txBody>
-          <a:bodyPr/>
-          <a:lstStyle/>
-          <a:p>
-            <a:r>
-              <a:rPr lang="en-US" dirty="0"/>
-              <a:t>El ejemplo continuo de toda la clase es RedExpress (Talleres 3 y 4). En su proyecto real suman también las brechas de seguridad (Taller 5) y de cumplimiento (Taller 6).</a:t>
-            </a:r>
-            <a:endParaRPr lang="en-US" dirty="0"/>
-          </a:p>
-        </p:txBody>
-      </p:sp>
-      <p:sp>
-        <p:nvSpPr>
-          <p:cNvPr id="4" name="Slide Number Placeholder 3"/>
-          <p:cNvSpPr>
-            <a:spLocks noGrp="1"/>
-          </p:cNvSpPr>
-          <p:nvPr>
-            <p:ph type="sldNum" sz="quarter" idx="10"/>
-          </p:nvPr>
-        </p:nvSpPr>
-        <p:spPr/>
-        <p:txBody>
-          <a:bodyPr/>
-          <a:lstStyle/>
-          <a:p>
-            <a:fld id="{F7021451-1387-4CA6-816F-3879F97B5CBC}" type="slidenum">
-              <a:rPr lang="en-US"/>
-              <a:t>2</a:t>
-            </a:fld>
-            <a:endParaRPr lang="en-US"/>
-          </a:p>
-        </p:txBody>
-      </p:sp>
-    </p:spTree>
-    <p:extLst>
-      <p:ext uri="{BB962C8B-B14F-4D97-AF65-F5344CB8AC3E}">
-        <p14:creationId xmlns:p14="http://schemas.microsoft.com/office/powerpoint/2010/main" val="1024086991"/>
-      </p:ext>
-    </p:extLst>
-  </p:cSld>
-  <p:clrMapOvr>
-    <a:masterClrMapping/>
-  </p:clrMapOvr>
-</p:notes>
-</file>
-
-<file path=ppt/notesSlides/notesSlide20.xml><?xml version="1.0" encoding="utf-8"?>
-<p:notes xmlns:a="http://schemas.openxmlformats.org/drawingml/2006/main" xmlns:r="http://schemas.openxmlformats.org/officeDocument/2006/relationships" xmlns:p="http://schemas.openxmlformats.org/presentationml/2006/main">
-  <p:cSld>
-    <p:spTree>
-      <p:nvGrpSpPr>
-        <p:cNvPr id="1" name=""/>
-        <p:cNvGrpSpPr/>
-        <p:nvPr/>
-      </p:nvGrpSpPr>
-      <p:grpSpPr>
-        <a:xfrm>
-          <a:off x="0" y="0"/>
-          <a:ext cx="0" cy="0"/>
-          <a:chOff x="0" y="0"/>
-          <a:chExt cx="0" cy="0"/>
-        </a:xfrm>
-      </p:grpSpPr>
-      <p:sp>
-        <p:nvSpPr>
-          <p:cNvPr id="2" name="Slide Image Placeholder 1"/>
-          <p:cNvSpPr>
-            <a:spLocks noGrp="1" noRot="1" noChangeAspect="1"/>
-          </p:cNvSpPr>
-          <p:nvPr>
-            <p:ph type="sldImg"/>
-          </p:nvPr>
-        </p:nvSpPr>
-        <p:spPr/>
-      </p:sp>
-      <p:sp>
-        <p:nvSpPr>
-          <p:cNvPr id="3" name="Notes Placeholder 2"/>
-          <p:cNvSpPr>
-            <a:spLocks noGrp="1"/>
-          </p:cNvSpPr>
-          <p:nvPr>
-            <p:ph type="body" idx="1"/>
-          </p:nvPr>
-        </p:nvSpPr>
-        <p:spPr/>
-        <p:txBody>
-          <a:bodyPr/>
-          <a:lstStyle/>
-          <a:p>
-            <a:r>
-              <a:rPr lang="en-US" dirty="0"/>
-              <a:t>Una decisión sin fecha ni disparador de revisión se vuelve dogma. Y una ADR buena lleva las alternativas descartadas con su razón y también las consecuencias negativas.</a:t>
-            </a:r>
-            <a:endParaRPr lang="en-US" dirty="0"/>
-          </a:p>
-        </p:txBody>
-      </p:sp>
-      <p:sp>
-        <p:nvSpPr>
-          <p:cNvPr id="4" name="Slide Number Placeholder 3"/>
-          <p:cNvSpPr>
-            <a:spLocks noGrp="1"/>
-          </p:cNvSpPr>
-          <p:nvPr>
-            <p:ph type="sldNum" sz="quarter" idx="10"/>
-          </p:nvPr>
-        </p:nvSpPr>
-        <p:spPr/>
-        <p:txBody>
-          <a:bodyPr/>
-          <a:lstStyle/>
-          <a:p>
-            <a:fld id="{F7021451-1387-4CA6-816F-3879F97B5CBC}" type="slidenum">
-              <a:rPr lang="en-US"/>
-              <a:t>20</a:t>
-            </a:fld>
-            <a:endParaRPr lang="en-US"/>
-          </a:p>
-        </p:txBody>
-      </p:sp>
-    </p:spTree>
-    <p:extLst>
-      <p:ext uri="{BB962C8B-B14F-4D97-AF65-F5344CB8AC3E}">
-        <p14:creationId xmlns:p14="http://schemas.microsoft.com/office/powerpoint/2010/main" val="1024086991"/>
-      </p:ext>
-    </p:extLst>
-  </p:cSld>
-  <p:clrMapOvr>
-    <a:masterClrMapping/>
-  </p:clrMapOvr>
-</p:notes>
-</file>
-
-<file path=ppt/notesSlides/notesSlide21.xml><?xml version="1.0" encoding="utf-8"?>
-<p:notes xmlns:a="http://schemas.openxmlformats.org/drawingml/2006/main" xmlns:r="http://schemas.openxmlformats.org/officeDocument/2006/relationships" xmlns:p="http://schemas.openxmlformats.org/presentationml/2006/main">
-  <p:cSld>
-    <p:spTree>
-      <p:nvGrpSpPr>
-        <p:cNvPr id="1" name=""/>
-        <p:cNvGrpSpPr/>
-        <p:nvPr/>
-      </p:nvGrpSpPr>
-      <p:grpSpPr>
-        <a:xfrm>
-          <a:off x="0" y="0"/>
-          <a:ext cx="0" cy="0"/>
-          <a:chOff x="0" y="0"/>
-          <a:chExt cx="0" cy="0"/>
-        </a:xfrm>
-      </p:grpSpPr>
-      <p:sp>
-        <p:nvSpPr>
-          <p:cNvPr id="2" name="Slide Image Placeholder 1"/>
-          <p:cNvSpPr>
-            <a:spLocks noGrp="1" noRot="1" noChangeAspect="1"/>
-          </p:cNvSpPr>
-          <p:nvPr>
-            <p:ph type="sldImg"/>
-          </p:nvPr>
-        </p:nvSpPr>
-        <p:spPr/>
-      </p:sp>
-      <p:sp>
-        <p:nvSpPr>
-          <p:cNvPr id="3" name="Notes Placeholder 2"/>
-          <p:cNvSpPr>
-            <a:spLocks noGrp="1"/>
-          </p:cNvSpPr>
-          <p:nvPr>
-            <p:ph type="body" idx="1"/>
-          </p:nvPr>
-        </p:nvSpPr>
-        <p:spPr/>
-        <p:txBody>
-          <a:bodyPr/>
-          <a:lstStyle/>
-          <a:p>
-            <a:r>
-              <a:rPr lang="en-US" dirty="0"/>
-              <a:t>Las capacidades salen de los procesos clave de la ficha del cliente (Taller 0), nombradas con verbo + objeto y sin tecnología. Cada paquete de trabajo se convierte en una fase del roadmap del Taller 9.</a:t>
-            </a:r>
-            <a:endParaRPr lang="en-US" dirty="0"/>
-          </a:p>
-        </p:txBody>
-      </p:sp>
-      <p:sp>
-        <p:nvSpPr>
-          <p:cNvPr id="4" name="Slide Number Placeholder 3"/>
-          <p:cNvSpPr>
-            <a:spLocks noGrp="1"/>
-          </p:cNvSpPr>
-          <p:nvPr>
-            <p:ph type="sldNum" sz="quarter" idx="10"/>
-          </p:nvPr>
-        </p:nvSpPr>
-        <p:spPr/>
-        <p:txBody>
-          <a:bodyPr/>
-          <a:lstStyle/>
-          <a:p>
-            <a:fld id="{F7021451-1387-4CA6-816F-3879F97B5CBC}" type="slidenum">
-              <a:rPr lang="en-US"/>
-              <a:t>21</a:t>
-            </a:fld>
-            <a:endParaRPr lang="en-US"/>
-          </a:p>
-        </p:txBody>
-      </p:sp>
-    </p:spTree>
-    <p:extLst>
-      <p:ext uri="{BB962C8B-B14F-4D97-AF65-F5344CB8AC3E}">
-        <p14:creationId xmlns:p14="http://schemas.microsoft.com/office/powerpoint/2010/main" val="1024086991"/>
-      </p:ext>
-    </p:extLst>
-  </p:cSld>
-  <p:clrMapOvr>
-    <a:masterClrMapping/>
-  </p:clrMapOvr>
-</p:notes>
-</file>
-
-<file path=ppt/notesSlides/notesSlide22.xml><?xml version="1.0" encoding="utf-8"?>
-<p:notes xmlns:a="http://schemas.openxmlformats.org/drawingml/2006/main" xmlns:r="http://schemas.openxmlformats.org/officeDocument/2006/relationships" xmlns:p="http://schemas.openxmlformats.org/presentationml/2006/main">
-  <p:cSld>
-    <p:spTree>
-      <p:nvGrpSpPr>
-        <p:cNvPr id="1" name=""/>
-        <p:cNvGrpSpPr/>
-        <p:nvPr/>
-      </p:nvGrpSpPr>
-      <p:grpSpPr>
-        <a:xfrm>
-          <a:off x="0" y="0"/>
-          <a:ext cx="0" cy="0"/>
-          <a:chOff x="0" y="0"/>
-          <a:chExt cx="0" cy="0"/>
-        </a:xfrm>
-      </p:grpSpPr>
-      <p:sp>
-        <p:nvSpPr>
-          <p:cNvPr id="2" name="Slide Image Placeholder 1"/>
-          <p:cNvSpPr>
-            <a:spLocks noGrp="1" noRot="1" noChangeAspect="1"/>
-          </p:cNvSpPr>
-          <p:nvPr>
-            <p:ph type="sldImg"/>
-          </p:nvPr>
-        </p:nvSpPr>
-        <p:spPr/>
-      </p:sp>
-      <p:sp>
-        <p:nvSpPr>
-          <p:cNvPr id="3" name="Notes Placeholder 2"/>
-          <p:cNvSpPr>
-            <a:spLocks noGrp="1"/>
-          </p:cNvSpPr>
-          <p:nvPr>
-            <p:ph type="body" idx="1"/>
-          </p:nvPr>
-        </p:nvSpPr>
-        <p:spPr/>
-        <p:txBody>
-          <a:bodyPr/>
-          <a:lstStyle/>
-          <a:p>
-            <a:r>
-              <a:rPr lang="en-US" dirty="0"/>
-              <a:t>Nunca documentar solo beneficios: sin los riesgos, el comité aprueba sin conocer las dependencias reales y las descubre tarde.</a:t>
-            </a:r>
-            <a:endParaRPr lang="en-US" dirty="0"/>
-          </a:p>
-        </p:txBody>
-      </p:sp>
-      <p:sp>
-        <p:nvSpPr>
-          <p:cNvPr id="4" name="Slide Number Placeholder 3"/>
-          <p:cNvSpPr>
-            <a:spLocks noGrp="1"/>
-          </p:cNvSpPr>
-          <p:nvPr>
-            <p:ph type="sldNum" sz="quarter" idx="10"/>
-          </p:nvPr>
-        </p:nvSpPr>
-        <p:spPr/>
-        <p:txBody>
-          <a:bodyPr/>
-          <a:lstStyle/>
-          <a:p>
-            <a:fld id="{F7021451-1387-4CA6-816F-3879F97B5CBC}" type="slidenum">
-              <a:rPr lang="en-US"/>
-              <a:t>22</a:t>
-            </a:fld>
-            <a:endParaRPr lang="en-US"/>
-          </a:p>
-        </p:txBody>
-      </p:sp>
-    </p:spTree>
-    <p:extLst>
-      <p:ext uri="{BB962C8B-B14F-4D97-AF65-F5344CB8AC3E}">
-        <p14:creationId xmlns:p14="http://schemas.microsoft.com/office/powerpoint/2010/main" val="1024086991"/>
-      </p:ext>
-    </p:extLst>
-  </p:cSld>
-  <p:clrMapOvr>
-    <a:masterClrMapping/>
-  </p:clrMapOvr>
-</p:notes>
-</file>
-
-<file path=ppt/notesSlides/notesSlide23.xml><?xml version="1.0" encoding="utf-8"?>
-<p:notes xmlns:a="http://schemas.openxmlformats.org/drawingml/2006/main" xmlns:r="http://schemas.openxmlformats.org/officeDocument/2006/relationships" xmlns:p="http://schemas.openxmlformats.org/presentationml/2006/main">
-  <p:cSld>
-    <p:spTree>
-      <p:nvGrpSpPr>
-        <p:cNvPr id="1" name=""/>
-        <p:cNvGrpSpPr/>
-        <p:nvPr/>
-      </p:nvGrpSpPr>
-      <p:grpSpPr>
-        <a:xfrm>
-          <a:off x="0" y="0"/>
-          <a:ext cx="0" cy="0"/>
-          <a:chOff x="0" y="0"/>
-          <a:chExt cx="0" cy="0"/>
-        </a:xfrm>
-      </p:grpSpPr>
-      <p:sp>
-        <p:nvSpPr>
-          <p:cNvPr id="2" name="Slide Image Placeholder 1"/>
-          <p:cNvSpPr>
-            <a:spLocks noGrp="1" noRot="1" noChangeAspect="1"/>
-          </p:cNvSpPr>
-          <p:nvPr>
-            <p:ph type="sldImg"/>
-          </p:nvPr>
-        </p:nvSpPr>
-        <p:spPr/>
-      </p:sp>
-      <p:sp>
-        <p:nvSpPr>
-          <p:cNvPr id="3" name="Notes Placeholder 2"/>
-          <p:cNvSpPr>
-            <a:spLocks noGrp="1"/>
-          </p:cNvSpPr>
-          <p:nvPr>
-            <p:ph type="body" idx="1"/>
-          </p:nvPr>
-        </p:nvSpPr>
-        <p:spPr/>
-        <p:txBody>
-          <a:bodyPr/>
-          <a:lstStyle/>
-          <a:p>
-            <a:r>
-              <a:rPr lang="en-US" dirty="0"/>
-              <a:t>Propuesta de tiempos (45 minutos); ajústelos a la sesión. Plantillas en el repo del Taller 7: plantilla_matriz_decision.md y plantilla_mejora_arquitectura.md.</a:t>
-            </a:r>
-            <a:endParaRPr lang="en-US" dirty="0"/>
-          </a:p>
-        </p:txBody>
-      </p:sp>
-      <p:sp>
-        <p:nvSpPr>
-          <p:cNvPr id="4" name="Slide Number Placeholder 3"/>
-          <p:cNvSpPr>
-            <a:spLocks noGrp="1"/>
-          </p:cNvSpPr>
-          <p:nvPr>
-            <p:ph type="sldNum" sz="quarter" idx="10"/>
-          </p:nvPr>
-        </p:nvSpPr>
-        <p:spPr/>
-        <p:txBody>
-          <a:bodyPr/>
-          <a:lstStyle/>
-          <a:p>
-            <a:fld id="{F7021451-1387-4CA6-816F-3879F97B5CBC}" type="slidenum">
-              <a:rPr lang="en-US"/>
-              <a:t>23</a:t>
-            </a:fld>
-            <a:endParaRPr lang="en-US"/>
-          </a:p>
-        </p:txBody>
-      </p:sp>
-    </p:spTree>
-    <p:extLst>
-      <p:ext uri="{BB962C8B-B14F-4D97-AF65-F5344CB8AC3E}">
-        <p14:creationId xmlns:p14="http://schemas.microsoft.com/office/powerpoint/2010/main" val="1024086991"/>
-      </p:ext>
-    </p:extLst>
-  </p:cSld>
-  <p:clrMapOvr>
-    <a:masterClrMapping/>
-  </p:clrMapOvr>
-</p:notes>
-</file>
-
-<file path=ppt/notesSlides/notesSlide24.xml><?xml version="1.0" encoding="utf-8"?>
-<p:notes xmlns:a="http://schemas.openxmlformats.org/drawingml/2006/main" xmlns:r="http://schemas.openxmlformats.org/officeDocument/2006/relationships" xmlns:p="http://schemas.openxmlformats.org/presentationml/2006/main">
-  <p:cSld>
-    <p:spTree>
-      <p:nvGrpSpPr>
-        <p:cNvPr id="1" name=""/>
-        <p:cNvGrpSpPr/>
-        <p:nvPr/>
-      </p:nvGrpSpPr>
-      <p:grpSpPr>
-        <a:xfrm>
-          <a:off x="0" y="0"/>
-          <a:ext cx="0" cy="0"/>
-          <a:chOff x="0" y="0"/>
-          <a:chExt cx="0" cy="0"/>
-        </a:xfrm>
-      </p:grpSpPr>
-      <p:sp>
-        <p:nvSpPr>
-          <p:cNvPr id="2" name="Slide Image Placeholder 1"/>
-          <p:cNvSpPr>
-            <a:spLocks noGrp="1" noRot="1" noChangeAspect="1"/>
-          </p:cNvSpPr>
-          <p:nvPr>
-            <p:ph type="sldImg"/>
-          </p:nvPr>
-        </p:nvSpPr>
-        <p:spPr/>
-      </p:sp>
-      <p:sp>
-        <p:nvSpPr>
-          <p:cNvPr id="3" name="Notes Placeholder 2"/>
-          <p:cNvSpPr>
-            <a:spLocks noGrp="1"/>
-          </p:cNvSpPr>
-          <p:nvPr>
-            <p:ph type="body" idx="1"/>
-          </p:nvPr>
-        </p:nvSpPr>
-        <p:spPr/>
-        <p:txBody>
-          <a:bodyPr/>
-          <a:lstStyle/>
-          <a:p>
-            <a:r>
-              <a:rPr lang="en-US" dirty="0"/>
-              <a:t/>
-            </a:r>
-            <a:endParaRPr lang="en-US" dirty="0"/>
-          </a:p>
-        </p:txBody>
-      </p:sp>
-      <p:sp>
-        <p:nvSpPr>
-          <p:cNvPr id="4" name="Slide Number Placeholder 3"/>
-          <p:cNvSpPr>
-            <a:spLocks noGrp="1"/>
-          </p:cNvSpPr>
-          <p:nvPr>
-            <p:ph type="sldNum" sz="quarter" idx="10"/>
-          </p:nvPr>
-        </p:nvSpPr>
-        <p:spPr/>
-        <p:txBody>
-          <a:bodyPr/>
-          <a:lstStyle/>
-          <a:p>
-            <a:fld id="{F7021451-1387-4CA6-816F-3879F97B5CBC}" type="slidenum">
-              <a:rPr lang="en-US"/>
-              <a:t>24</a:t>
-            </a:fld>
-            <a:endParaRPr lang="en-US"/>
-          </a:p>
-        </p:txBody>
-      </p:sp>
-    </p:spTree>
-    <p:extLst>
-      <p:ext uri="{BB962C8B-B14F-4D97-AF65-F5344CB8AC3E}">
-        <p14:creationId xmlns:p14="http://schemas.microsoft.com/office/powerpoint/2010/main" val="1024086991"/>
-      </p:ext>
-    </p:extLst>
-  </p:cSld>
-  <p:clrMapOvr>
-    <a:masterClrMapping/>
-  </p:clrMapOvr>
-</p:notes>
-</file>
-
-<file path=ppt/notesSlides/notesSlide3.xml><?xml version="1.0" encoding="utf-8"?>
-<p:notes xmlns:a="http://schemas.openxmlformats.org/drawingml/2006/main" xmlns:r="http://schemas.openxmlformats.org/officeDocument/2006/relationships" xmlns:p="http://schemas.openxmlformats.org/presentationml/2006/main">
-  <p:cSld>
-    <p:spTree>
-      <p:nvGrpSpPr>
-        <p:cNvPr id="1" name=""/>
-        <p:cNvGrpSpPr/>
-        <p:nvPr/>
-      </p:nvGrpSpPr>
-      <p:grpSpPr>
-        <a:xfrm>
-          <a:off x="0" y="0"/>
-          <a:ext cx="0" cy="0"/>
-          <a:chOff x="0" y="0"/>
-          <a:chExt cx="0" cy="0"/>
-        </a:xfrm>
-      </p:grpSpPr>
-      <p:sp>
-        <p:nvSpPr>
-          <p:cNvPr id="2" name="Slide Image Placeholder 1"/>
-          <p:cNvSpPr>
-            <a:spLocks noGrp="1" noRot="1" noChangeAspect="1"/>
-          </p:cNvSpPr>
-          <p:nvPr>
-            <p:ph type="sldImg"/>
-          </p:nvPr>
-        </p:nvSpPr>
-        <p:spPr/>
-      </p:sp>
-      <p:sp>
-        <p:nvSpPr>
-          <p:cNvPr id="3" name="Notes Placeholder 2"/>
-          <p:cNvSpPr>
-            <a:spLocks noGrp="1"/>
-          </p:cNvSpPr>
-          <p:nvPr>
-            <p:ph type="body" idx="1"/>
-          </p:nvPr>
-        </p:nvSpPr>
-        <p:spPr/>
-        <p:txBody>
-          <a:bodyPr/>
-          <a:lstStyle/>
-          <a:p>
-            <a:r>
-              <a:rPr lang="en-US" dirty="0"/>
-              <a:t>No es un diagrama nuevo: es el C2/mapa de infraestructura resumido. El objetivo de esta lámina es recordar dónde estamos parados antes de proponer nada.</a:t>
-            </a:r>
-            <a:endParaRPr lang="en-US" dirty="0"/>
-          </a:p>
-        </p:txBody>
-      </p:sp>
-      <p:sp>
-        <p:nvSpPr>
-          <p:cNvPr id="4" name="Slide Number Placeholder 3"/>
-          <p:cNvSpPr>
-            <a:spLocks noGrp="1"/>
-          </p:cNvSpPr>
-          <p:nvPr>
-            <p:ph type="sldNum" sz="quarter" idx="10"/>
-          </p:nvPr>
-        </p:nvSpPr>
-        <p:spPr/>
-        <p:txBody>
-          <a:bodyPr/>
-          <a:lstStyle/>
-          <a:p>
-            <a:fld id="{F7021451-1387-4CA6-816F-3879F97B5CBC}" type="slidenum">
-              <a:rPr lang="en-US"/>
-              <a:t>3</a:t>
-            </a:fld>
-            <a:endParaRPr lang="en-US"/>
-          </a:p>
-        </p:txBody>
-      </p:sp>
-    </p:spTree>
-    <p:extLst>
-      <p:ext uri="{BB962C8B-B14F-4D97-AF65-F5344CB8AC3E}">
-        <p14:creationId xmlns:p14="http://schemas.microsoft.com/office/powerpoint/2010/main" val="1024086991"/>
-      </p:ext>
-    </p:extLst>
-  </p:cSld>
-  <p:clrMapOvr>
-    <a:masterClrMapping/>
-  </p:clrMapOvr>
-</p:notes>
-</file>
-
-<file path=ppt/notesSlides/notesSlide4.xml><?xml version="1.0" encoding="utf-8"?>
-<p:notes xmlns:a="http://schemas.openxmlformats.org/drawingml/2006/main" xmlns:r="http://schemas.openxmlformats.org/officeDocument/2006/relationships" xmlns:p="http://schemas.openxmlformats.org/presentationml/2006/main">
-  <p:cSld>
-    <p:spTree>
-      <p:nvGrpSpPr>
-        <p:cNvPr id="1" name=""/>
-        <p:cNvGrpSpPr/>
-        <p:nvPr/>
-      </p:nvGrpSpPr>
-      <p:grpSpPr>
-        <a:xfrm>
-          <a:off x="0" y="0"/>
-          <a:ext cx="0" cy="0"/>
-          <a:chOff x="0" y="0"/>
-          <a:chExt cx="0" cy="0"/>
-        </a:xfrm>
-      </p:grpSpPr>
-      <p:sp>
-        <p:nvSpPr>
-          <p:cNvPr id="2" name="Slide Image Placeholder 1"/>
-          <p:cNvSpPr>
-            <a:spLocks noGrp="1" noRot="1" noChangeAspect="1"/>
-          </p:cNvSpPr>
-          <p:nvPr>
-            <p:ph type="sldImg"/>
-          </p:nvPr>
-        </p:nvSpPr>
-        <p:spPr/>
-      </p:sp>
-      <p:sp>
-        <p:nvSpPr>
-          <p:cNvPr id="3" name="Notes Placeholder 2"/>
-          <p:cNvSpPr>
-            <a:spLocks noGrp="1"/>
-          </p:cNvSpPr>
-          <p:nvPr>
-            <p:ph type="body" idx="1"/>
-          </p:nvPr>
-        </p:nvSpPr>
-        <p:spPr/>
-        <p:txBody>
-          <a:bodyPr/>
-          <a:lstStyle/>
-          <a:p>
-            <a:r>
-              <a:rPr lang="en-US" dirty="0"/>
-              <a:t>Esta es la regla que sostiene todo lo demás: cada elemento del TO-BE debe poder rastrearse a una brecha de un entregable anterior.</a:t>
-            </a:r>
-            <a:endParaRPr lang="en-US" dirty="0"/>
-          </a:p>
-        </p:txBody>
-      </p:sp>
-      <p:sp>
-        <p:nvSpPr>
-          <p:cNvPr id="4" name="Slide Number Placeholder 3"/>
-          <p:cNvSpPr>
-            <a:spLocks noGrp="1"/>
-          </p:cNvSpPr>
-          <p:nvPr>
-            <p:ph type="sldNum" sz="quarter" idx="10"/>
-          </p:nvPr>
-        </p:nvSpPr>
-        <p:spPr/>
-        <p:txBody>
-          <a:bodyPr/>
-          <a:lstStyle/>
-          <a:p>
-            <a:fld id="{F7021451-1387-4CA6-816F-3879F97B5CBC}" type="slidenum">
-              <a:rPr lang="en-US"/>
-              <a:t>4</a:t>
-            </a:fld>
-            <a:endParaRPr lang="en-US"/>
-          </a:p>
-        </p:txBody>
-      </p:sp>
-    </p:spTree>
-    <p:extLst>
-      <p:ext uri="{BB962C8B-B14F-4D97-AF65-F5344CB8AC3E}">
-        <p14:creationId xmlns:p14="http://schemas.microsoft.com/office/powerpoint/2010/main" val="1024086991"/>
-      </p:ext>
-    </p:extLst>
-  </p:cSld>
-  <p:clrMapOvr>
-    <a:masterClrMapping/>
-  </p:clrMapOvr>
-</p:notes>
-</file>
-
-<file path=ppt/notesSlides/notesSlide5.xml><?xml version="1.0" encoding="utf-8"?>
-<p:notes xmlns:a="http://schemas.openxmlformats.org/drawingml/2006/main" xmlns:r="http://schemas.openxmlformats.org/officeDocument/2006/relationships" xmlns:p="http://schemas.openxmlformats.org/presentationml/2006/main">
-  <p:cSld>
-    <p:spTree>
-      <p:nvGrpSpPr>
-        <p:cNvPr id="1" name=""/>
-        <p:cNvGrpSpPr/>
-        <p:nvPr/>
-      </p:nvGrpSpPr>
-      <p:grpSpPr>
-        <a:xfrm>
-          <a:off x="0" y="0"/>
-          <a:ext cx="0" cy="0"/>
-          <a:chOff x="0" y="0"/>
-          <a:chExt cx="0" cy="0"/>
-        </a:xfrm>
-      </p:grpSpPr>
-      <p:sp>
-        <p:nvSpPr>
-          <p:cNvPr id="2" name="Slide Image Placeholder 1"/>
-          <p:cNvSpPr>
-            <a:spLocks noGrp="1" noRot="1" noChangeAspect="1"/>
-          </p:cNvSpPr>
-          <p:nvPr>
-            <p:ph type="sldImg"/>
-          </p:nvPr>
-        </p:nvSpPr>
-        <p:spPr/>
-      </p:sp>
-      <p:sp>
-        <p:nvSpPr>
-          <p:cNvPr id="3" name="Notes Placeholder 2"/>
-          <p:cNvSpPr>
-            <a:spLocks noGrp="1"/>
-          </p:cNvSpPr>
-          <p:nvPr>
-            <p:ph type="body" idx="1"/>
-          </p:nvPr>
-        </p:nvSpPr>
-        <p:spPr/>
-        <p:txBody>
-          <a:bodyPr/>
-          <a:lstStyle/>
-          <a:p>
-            <a:r>
-              <a:rPr lang="en-US" dirty="0"/>
-              <a:t>Las tres preguntas orientadoras son de la guía oficial de la actividad de mejora. En clase usamos solo brechas técnicas porque son las únicas completamente diagnosticadas; en el proyecto real se suman seguridad y normatividad.</a:t>
-            </a:r>
-            <a:endParaRPr lang="en-US" dirty="0"/>
-          </a:p>
-        </p:txBody>
-      </p:sp>
-      <p:sp>
-        <p:nvSpPr>
-          <p:cNvPr id="4" name="Slide Number Placeholder 3"/>
-          <p:cNvSpPr>
-            <a:spLocks noGrp="1"/>
-          </p:cNvSpPr>
-          <p:nvPr>
-            <p:ph type="sldNum" sz="quarter" idx="10"/>
-          </p:nvPr>
-        </p:nvSpPr>
-        <p:spPr/>
-        <p:txBody>
-          <a:bodyPr/>
-          <a:lstStyle/>
-          <a:p>
-            <a:fld id="{F7021451-1387-4CA6-816F-3879F97B5CBC}" type="slidenum">
-              <a:rPr lang="en-US"/>
-              <a:t>5</a:t>
-            </a:fld>
-            <a:endParaRPr lang="en-US"/>
-          </a:p>
-        </p:txBody>
-      </p:sp>
-    </p:spTree>
-    <p:extLst>
-      <p:ext uri="{BB962C8B-B14F-4D97-AF65-F5344CB8AC3E}">
-        <p14:creationId xmlns:p14="http://schemas.microsoft.com/office/powerpoint/2010/main" val="1024086991"/>
-      </p:ext>
-    </p:extLst>
-  </p:cSld>
-  <p:clrMapOvr>
-    <a:masterClrMapping/>
-  </p:clrMapOvr>
-</p:notes>
-</file>
-
-<file path=ppt/notesSlides/notesSlide6.xml><?xml version="1.0" encoding="utf-8"?>
-<p:notes xmlns:a="http://schemas.openxmlformats.org/drawingml/2006/main" xmlns:r="http://schemas.openxmlformats.org/officeDocument/2006/relationships" xmlns:p="http://schemas.openxmlformats.org/presentationml/2006/main">
-  <p:cSld>
-    <p:spTree>
-      <p:nvGrpSpPr>
-        <p:cNvPr id="1" name=""/>
-        <p:cNvGrpSpPr/>
-        <p:nvPr/>
-      </p:nvGrpSpPr>
-      <p:grpSpPr>
-        <a:xfrm>
-          <a:off x="0" y="0"/>
-          <a:ext cx="0" cy="0"/>
-          <a:chOff x="0" y="0"/>
-          <a:chExt cx="0" cy="0"/>
-        </a:xfrm>
-      </p:grpSpPr>
-      <p:sp>
-        <p:nvSpPr>
-          <p:cNvPr id="2" name="Slide Image Placeholder 1"/>
-          <p:cNvSpPr>
-            <a:spLocks noGrp="1" noRot="1" noChangeAspect="1"/>
-          </p:cNvSpPr>
-          <p:nvPr>
-            <p:ph type="sldImg"/>
-          </p:nvPr>
-        </p:nvSpPr>
-        <p:spPr/>
-      </p:sp>
-      <p:sp>
-        <p:nvSpPr>
-          <p:cNvPr id="3" name="Notes Placeholder 2"/>
-          <p:cNvSpPr>
-            <a:spLocks noGrp="1"/>
-          </p:cNvSpPr>
-          <p:nvPr>
-            <p:ph type="body" idx="1"/>
-          </p:nvPr>
-        </p:nvSpPr>
-        <p:spPr/>
-        <p:txBody>
-          <a:bodyPr/>
-          <a:lstStyle/>
-          <a:p>
-            <a:r>
-              <a:rPr lang="en-US" dirty="0"/>
-              <a:t>Regla: no se descarta nada todavía. Si alguna idea es un agente de IA (como el chatbot #7), no se modela como caja negra: se usa el patrón de sistemas agénticos de la guía ArchiMate.</a:t>
-            </a:r>
-            <a:endParaRPr lang="en-US" dirty="0"/>
-          </a:p>
-        </p:txBody>
-      </p:sp>
-      <p:sp>
-        <p:nvSpPr>
-          <p:cNvPr id="4" name="Slide Number Placeholder 3"/>
-          <p:cNvSpPr>
-            <a:spLocks noGrp="1"/>
-          </p:cNvSpPr>
-          <p:nvPr>
-            <p:ph type="sldNum" sz="quarter" idx="10"/>
-          </p:nvPr>
-        </p:nvSpPr>
-        <p:spPr/>
-        <p:txBody>
-          <a:bodyPr/>
-          <a:lstStyle/>
-          <a:p>
-            <a:fld id="{F7021451-1387-4CA6-816F-3879F97B5CBC}" type="slidenum">
-              <a:rPr lang="en-US"/>
-              <a:t>6</a:t>
-            </a:fld>
-            <a:endParaRPr lang="en-US"/>
-          </a:p>
-        </p:txBody>
-      </p:sp>
-    </p:spTree>
-    <p:extLst>
-      <p:ext uri="{BB962C8B-B14F-4D97-AF65-F5344CB8AC3E}">
-        <p14:creationId xmlns:p14="http://schemas.microsoft.com/office/powerpoint/2010/main" val="1024086991"/>
-      </p:ext>
-    </p:extLst>
-  </p:cSld>
-  <p:clrMapOvr>
-    <a:masterClrMapping/>
-  </p:clrMapOvr>
-</p:notes>
-</file>
-
-<file path=ppt/notesSlides/notesSlide7.xml><?xml version="1.0" encoding="utf-8"?>
-<p:notes xmlns:a="http://schemas.openxmlformats.org/drawingml/2006/main" xmlns:r="http://schemas.openxmlformats.org/officeDocument/2006/relationships" xmlns:p="http://schemas.openxmlformats.org/presentationml/2006/main">
-  <p:cSld>
-    <p:spTree>
-      <p:nvGrpSpPr>
-        <p:cNvPr id="1" name=""/>
-        <p:cNvGrpSpPr/>
-        <p:nvPr/>
-      </p:nvGrpSpPr>
-      <p:grpSpPr>
-        <a:xfrm>
-          <a:off x="0" y="0"/>
-          <a:ext cx="0" cy="0"/>
-          <a:chOff x="0" y="0"/>
-          <a:chExt cx="0" cy="0"/>
-        </a:xfrm>
-      </p:grpSpPr>
-      <p:sp>
-        <p:nvSpPr>
-          <p:cNvPr id="2" name="Slide Image Placeholder 1"/>
-          <p:cNvSpPr>
-            <a:spLocks noGrp="1" noRot="1" noChangeAspect="1"/>
-          </p:cNvSpPr>
-          <p:nvPr>
-            <p:ph type="sldImg"/>
-          </p:nvPr>
-        </p:nvSpPr>
-        <p:spPr/>
-      </p:sp>
-      <p:sp>
-        <p:nvSpPr>
-          <p:cNvPr id="3" name="Notes Placeholder 2"/>
-          <p:cNvSpPr>
-            <a:spLocks noGrp="1"/>
-          </p:cNvSpPr>
-          <p:nvPr>
-            <p:ph type="body" idx="1"/>
-          </p:nvPr>
-        </p:nvSpPr>
-        <p:spPr/>
-        <p:txBody>
-          <a:bodyPr/>
-          <a:lstStyle/>
-          <a:p>
-            <a:r>
-              <a:rPr lang="en-US" dirty="0"/>
-              <a:t>Priorizar cruza impacto y esfuerzo. Los quick wins van primero. Ahora tomamos la prioridad 1 (balanceador) y más adelante veremos cómo decidir cómo resolverla.</a:t>
-            </a:r>
-            <a:endParaRPr lang="en-US" dirty="0"/>
-          </a:p>
-        </p:txBody>
-      </p:sp>
-      <p:sp>
-        <p:nvSpPr>
-          <p:cNvPr id="4" name="Slide Number Placeholder 3"/>
-          <p:cNvSpPr>
-            <a:spLocks noGrp="1"/>
-          </p:cNvSpPr>
-          <p:nvPr>
-            <p:ph type="sldNum" sz="quarter" idx="10"/>
-          </p:nvPr>
-        </p:nvSpPr>
-        <p:spPr/>
-        <p:txBody>
-          <a:bodyPr/>
-          <a:lstStyle/>
-          <a:p>
-            <a:fld id="{F7021451-1387-4CA6-816F-3879F97B5CBC}" type="slidenum">
-              <a:rPr lang="en-US"/>
-              <a:t>7</a:t>
-            </a:fld>
-            <a:endParaRPr lang="en-US"/>
-          </a:p>
-        </p:txBody>
-      </p:sp>
-    </p:spTree>
-    <p:extLst>
-      <p:ext uri="{BB962C8B-B14F-4D97-AF65-F5344CB8AC3E}">
-        <p14:creationId xmlns:p14="http://schemas.microsoft.com/office/powerpoint/2010/main" val="1024086991"/>
-      </p:ext>
-    </p:extLst>
-  </p:cSld>
-  <p:clrMapOvr>
-    <a:masterClrMapping/>
-  </p:clrMapOvr>
-</p:notes>
-</file>
-
-<file path=ppt/notesSlides/notesSlide8.xml><?xml version="1.0" encoding="utf-8"?>
-<p:notes xmlns:a="http://schemas.openxmlformats.org/drawingml/2006/main" xmlns:r="http://schemas.openxmlformats.org/officeDocument/2006/relationships" xmlns:p="http://schemas.openxmlformats.org/presentationml/2006/main">
-  <p:cSld>
-    <p:spTree>
-      <p:nvGrpSpPr>
-        <p:cNvPr id="1" name=""/>
-        <p:cNvGrpSpPr/>
-        <p:nvPr/>
-      </p:nvGrpSpPr>
-      <p:grpSpPr>
-        <a:xfrm>
-          <a:off x="0" y="0"/>
-          <a:ext cx="0" cy="0"/>
-          <a:chOff x="0" y="0"/>
-          <a:chExt cx="0" cy="0"/>
-        </a:xfrm>
-      </p:grpSpPr>
-      <p:sp>
-        <p:nvSpPr>
-          <p:cNvPr id="2" name="Slide Image Placeholder 1"/>
-          <p:cNvSpPr>
-            <a:spLocks noGrp="1" noRot="1" noChangeAspect="1"/>
-          </p:cNvSpPr>
-          <p:nvPr>
-            <p:ph type="sldImg"/>
-          </p:nvPr>
-        </p:nvSpPr>
-        <p:spPr/>
-      </p:sp>
-      <p:sp>
-        <p:nvSpPr>
-          <p:cNvPr id="3" name="Notes Placeholder 2"/>
-          <p:cNvSpPr>
-            <a:spLocks noGrp="1"/>
-          </p:cNvSpPr>
-          <p:nvPr>
-            <p:ph type="body" idx="1"/>
-          </p:nvPr>
-        </p:nvSpPr>
-        <p:spPr/>
-        <p:txBody>
-          <a:bodyPr/>
-          <a:lstStyle/>
-          <a:p>
-            <a:r>
-              <a:rPr lang="en-US" dirty="0"/>
-              <a:t>El TO-BE de aplicaciones extiende el C2 del Taller 3 y el de tecnología extiende el mapa del Taller 4. Si alguna mitigación STRIDE del Taller 5 protege uno de estos componentes, se declara explícitamente.</a:t>
-            </a:r>
-            <a:endParaRPr lang="en-US" dirty="0"/>
-          </a:p>
-        </p:txBody>
-      </p:sp>
-      <p:sp>
-        <p:nvSpPr>
-          <p:cNvPr id="4" name="Slide Number Placeholder 3"/>
-          <p:cNvSpPr>
-            <a:spLocks noGrp="1"/>
-          </p:cNvSpPr>
-          <p:nvPr>
-            <p:ph type="sldNum" sz="quarter" idx="10"/>
-          </p:nvPr>
-        </p:nvSpPr>
-        <p:spPr/>
-        <p:txBody>
-          <a:bodyPr/>
-          <a:lstStyle/>
-          <a:p>
-            <a:fld id="{F7021451-1387-4CA6-816F-3879F97B5CBC}" type="slidenum">
-              <a:rPr lang="en-US"/>
-              <a:t>8</a:t>
-            </a:fld>
-            <a:endParaRPr lang="en-US"/>
-          </a:p>
-        </p:txBody>
-      </p:sp>
-    </p:spTree>
-    <p:extLst>
-      <p:ext uri="{BB962C8B-B14F-4D97-AF65-F5344CB8AC3E}">
-        <p14:creationId xmlns:p14="http://schemas.microsoft.com/office/powerpoint/2010/main" val="1024086991"/>
-      </p:ext>
-    </p:extLst>
-  </p:cSld>
-  <p:clrMapOvr>
-    <a:masterClrMapping/>
-  </p:clrMapOvr>
-</p:notes>
-</file>
-
-<file path=ppt/notesSlides/notesSlide9.xml><?xml version="1.0" encoding="utf-8"?>
-<p:notes xmlns:a="http://schemas.openxmlformats.org/drawingml/2006/main" xmlns:r="http://schemas.openxmlformats.org/officeDocument/2006/relationships" xmlns:p="http://schemas.openxmlformats.org/presentationml/2006/main">
-  <p:cSld>
-    <p:spTree>
-      <p:nvGrpSpPr>
-        <p:cNvPr id="1" name=""/>
-        <p:cNvGrpSpPr/>
-        <p:nvPr/>
-      </p:nvGrpSpPr>
-      <p:grpSpPr>
-        <a:xfrm>
-          <a:off x="0" y="0"/>
-          <a:ext cx="0" cy="0"/>
-          <a:chOff x="0" y="0"/>
-          <a:chExt cx="0" cy="0"/>
-        </a:xfrm>
-      </p:grpSpPr>
-      <p:sp>
-        <p:nvSpPr>
-          <p:cNvPr id="2" name="Slide Image Placeholder 1"/>
-          <p:cNvSpPr>
-            <a:spLocks noGrp="1" noRot="1" noChangeAspect="1"/>
-          </p:cNvSpPr>
-          <p:nvPr>
-            <p:ph type="sldImg"/>
-          </p:nvPr>
-        </p:nvSpPr>
-        <p:spPr/>
-      </p:sp>
-      <p:sp>
-        <p:nvSpPr>
-          <p:cNvPr id="3" name="Notes Placeholder 2"/>
-          <p:cNvSpPr>
-            <a:spLocks noGrp="1"/>
-          </p:cNvSpPr>
-          <p:nvPr>
-            <p:ph type="body" idx="1"/>
-          </p:nvPr>
-        </p:nvSpPr>
-        <p:spPr/>
-        <p:txBody>
-          <a:bodyPr/>
-          <a:lstStyle/>
-          <a:p>
-            <a:r>
-              <a:rPr lang="en-US" dirty="0"/>
-              <a:t>Los valores en dólares, semanas y envíos por hora de las siguientes láminas son supuestos del ejemplo. En el proyecto real se reemplazan con datos del cliente.</a:t>
-            </a:r>
-            <a:endParaRPr lang="en-US" dirty="0"/>
-          </a:p>
-        </p:txBody>
-      </p:sp>
-      <p:sp>
-        <p:nvSpPr>
-          <p:cNvPr id="4" name="Slide Number Placeholder 3"/>
-          <p:cNvSpPr>
-            <a:spLocks noGrp="1"/>
-          </p:cNvSpPr>
-          <p:nvPr>
-            <p:ph type="sldNum" sz="quarter" idx="10"/>
-          </p:nvPr>
-        </p:nvSpPr>
-        <p:spPr/>
-        <p:txBody>
-          <a:bodyPr/>
-          <a:lstStyle/>
-          <a:p>
-            <a:fld id="{F7021451-1387-4CA6-816F-3879F97B5CBC}" type="slidenum">
-              <a:rPr lang="en-US"/>
-              <a:t>9</a:t>
-            </a:fld>
-            <a:endParaRPr lang="en-US"/>
-          </a:p>
-        </p:txBody>
-      </p:sp>
-    </p:spTree>
-    <p:extLst>
-      <p:ext uri="{BB962C8B-B14F-4D97-AF65-F5344CB8AC3E}">
-        <p14:creationId xmlns:p14="http://schemas.microsoft.com/office/powerpoint/2010/main" val="1024086991"/>
-      </p:ext>
-    </p:extLst>
-  </p:cSld>
-  <p:clrMapOvr>
-    <a:masterClrMapping/>
-  </p:clrMapOvr>
-</p:notes>
 </file>
 
 <file path=ppt/slideLayouts/slideLayout1.xml><?xml version="1.0" encoding="utf-8"?>
@@ -9940,7 +7828,7 @@
                           <a:ea typeface="Calibri" pitchFamily="34" charset="-122"/>
                           <a:cs typeface="Calibri" pitchFamily="34" charset="-120"/>
                         </a:rPr>
-                        <a:t>4-6 semanas</a:t>
+                        <a:t>6 semanas (+2 de pruebas)</a:t>
                       </a:r>
                       <a:endParaRPr lang="en-US" sz="1200" dirty="0">
                         <a:latin typeface="Calibri" charset="0"/>

</xml_diff>